<commit_message>
Added ECLR link and edited presentation
</commit_message>
<xml_diff>
--- a/DEE2025 workshop slides Becker Zhu present.pptx
+++ b/DEE2025 workshop slides Becker Zhu present.pptx
@@ -6554,7 +6554,7 @@
           <a:p>
             <a:fld id="{B9646C07-FEB6-A24A-825A-896B832821A6}" type="datetimeFigureOut">
               <a:rPr lang="en-US" smtClean="0"/>
-              <a:t>9/10/2025</a:t>
+              <a:t>9/11/2025</a:t>
             </a:fld>
             <a:endParaRPr lang="en-US"/>
           </a:p>
@@ -7835,7 +7835,7 @@
           <a:p>
             <a:fld id="{71FA5425-D0E0-484F-B15E-0A4EA02E289E}" type="datetime1">
               <a:rPr lang="en-GB" smtClean="0"/>
-              <a:t>10/09/2025</a:t>
+              <a:t>11/09/2025</a:t>
             </a:fld>
             <a:endParaRPr lang="en-US"/>
           </a:p>
@@ -8035,7 +8035,7 @@
           <a:p>
             <a:fld id="{987EFAB7-DC2F-4341-A3F4-3B259F642E64}" type="datetime1">
               <a:rPr lang="en-GB" smtClean="0"/>
-              <a:t>10/09/2025</a:t>
+              <a:t>11/09/2025</a:t>
             </a:fld>
             <a:endParaRPr lang="en-US"/>
           </a:p>
@@ -8245,7 +8245,7 @@
           <a:p>
             <a:fld id="{9A929D7A-6CF4-C549-8943-5949BE4713C0}" type="datetime1">
               <a:rPr lang="en-GB" smtClean="0"/>
-              <a:t>10/09/2025</a:t>
+              <a:t>11/09/2025</a:t>
             </a:fld>
             <a:endParaRPr lang="en-US"/>
           </a:p>
@@ -8445,7 +8445,7 @@
           <a:p>
             <a:fld id="{86CDD7E2-17AC-6446-8903-FFCACE8EEA26}" type="datetime1">
               <a:rPr lang="en-GB" smtClean="0"/>
-              <a:t>10/09/2025</a:t>
+              <a:t>11/09/2025</a:t>
             </a:fld>
             <a:endParaRPr lang="en-US"/>
           </a:p>
@@ -8721,7 +8721,7 @@
           <a:p>
             <a:fld id="{E03976D6-966A-D142-8529-9E7031701B8F}" type="datetime1">
               <a:rPr lang="en-GB" smtClean="0"/>
-              <a:t>10/09/2025</a:t>
+              <a:t>11/09/2025</a:t>
             </a:fld>
             <a:endParaRPr lang="en-US"/>
           </a:p>
@@ -8989,7 +8989,7 @@
           <a:p>
             <a:fld id="{7D51280D-8B40-964A-9FB5-9FB05CBC6AE6}" type="datetime1">
               <a:rPr lang="en-GB" smtClean="0"/>
-              <a:t>10/09/2025</a:t>
+              <a:t>11/09/2025</a:t>
             </a:fld>
             <a:endParaRPr lang="en-US"/>
           </a:p>
@@ -9404,7 +9404,7 @@
           <a:p>
             <a:fld id="{2E4D55EC-1300-934C-A307-97BF0D87F4B8}" type="datetime1">
               <a:rPr lang="en-GB" smtClean="0"/>
-              <a:t>10/09/2025</a:t>
+              <a:t>11/09/2025</a:t>
             </a:fld>
             <a:endParaRPr lang="en-US"/>
           </a:p>
@@ -9546,7 +9546,7 @@
           <a:p>
             <a:fld id="{CEDA83F1-7D91-A447-8BC1-6454E5928C32}" type="datetime1">
               <a:rPr lang="en-GB" smtClean="0"/>
-              <a:t>10/09/2025</a:t>
+              <a:t>11/09/2025</a:t>
             </a:fld>
             <a:endParaRPr lang="en-US"/>
           </a:p>
@@ -9659,7 +9659,7 @@
           <a:p>
             <a:fld id="{BB2F8029-4CC3-9447-8737-15AB747FDC2F}" type="datetime1">
               <a:rPr lang="en-GB" smtClean="0"/>
-              <a:t>10/09/2025</a:t>
+              <a:t>11/09/2025</a:t>
             </a:fld>
             <a:endParaRPr lang="en-US"/>
           </a:p>
@@ -9972,7 +9972,7 @@
           <a:p>
             <a:fld id="{C94F589B-65DF-5F41-A074-7AE6E4159B30}" type="datetime1">
               <a:rPr lang="en-GB" smtClean="0"/>
-              <a:t>10/09/2025</a:t>
+              <a:t>11/09/2025</a:t>
             </a:fld>
             <a:endParaRPr lang="en-US"/>
           </a:p>
@@ -10261,7 +10261,7 @@
           <a:p>
             <a:fld id="{5F98D526-017B-6545-BB5E-DA0E3938C22C}" type="datetime1">
               <a:rPr lang="en-GB" smtClean="0"/>
-              <a:t>10/09/2025</a:t>
+              <a:t>11/09/2025</a:t>
             </a:fld>
             <a:endParaRPr lang="en-US"/>
           </a:p>
@@ -10504,7 +10504,7 @@
           <a:p>
             <a:fld id="{6387B4AE-C3DB-F74E-B579-B56945C49C81}" type="datetime1">
               <a:rPr lang="en-GB" smtClean="0"/>
-              <a:t>10/09/2025</a:t>
+              <a:t>11/09/2025</a:t>
             </a:fld>
             <a:endParaRPr lang="en-US"/>
           </a:p>
@@ -18116,12 +18116,6 @@
             <a:r>
               <a:rPr lang="en-GB" dirty="0"/>
               <a:t>Evaluation Evidence (Case Study: Aston, Manchester)</a:t>
-            </a:r>
-          </a:p>
-          <a:p>
-            <a:r>
-              <a:rPr lang="en-GB" dirty="0"/>
-              <a:t>Interactive Activities</a:t>
             </a:r>
           </a:p>
           <a:p>
@@ -24706,17 +24700,25 @@
           <a:p>
             <a:r>
               <a:rPr lang="en-US" b="1" dirty="0"/>
-              <a:t>Interactive Activities</a:t>
+              <a:t>Complete </a:t>
+            </a:r>
+            <a:r>
+              <a:rPr lang="en-US" b="1" dirty="0" err="1"/>
+              <a:t>Workthrough</a:t>
+            </a:r>
+            <a:r>
+              <a:rPr lang="en-US" b="1" dirty="0"/>
+              <a:t> and Templates</a:t>
             </a:r>
           </a:p>
         </p:txBody>
       </p:sp>
       <p:sp>
         <p:nvSpPr>
-          <p:cNvPr id="3" name="Content Placeholder 2">
+          <p:cNvPr id="5" name="Content Placeholder 4">
             <a:extLst>
               <a:ext uri="{FF2B5EF4-FFF2-40B4-BE49-F238E27FC236}">
-                <a16:creationId xmlns:a16="http://schemas.microsoft.com/office/drawing/2014/main" id="{D2FC0861-9226-2BB8-B3FF-0648B971E549}"/>
+                <a16:creationId xmlns:a16="http://schemas.microsoft.com/office/drawing/2014/main" id="{9CEDCF1E-2A7B-ADA3-8EC4-88A8D88C5D8D}"/>
               </a:ext>
             </a:extLst>
           </p:cNvPr>
@@ -24729,69 +24731,94 @@
         </p:nvSpPr>
         <p:spPr/>
         <p:txBody>
-          <a:bodyPr>
-            <a:normAutofit lnSpcReduction="10000"/>
+          <a:bodyPr/>
+          <a:lstStyle/>
+          <a:p>
+            <a:r>
+              <a:rPr lang="en-GB" dirty="0"/>
+              <a:t>DEE2025 Coding </a:t>
+            </a:r>
+            <a:r>
+              <a:rPr lang="en-GB" dirty="0" err="1"/>
+              <a:t>Github</a:t>
+            </a:r>
+            <a:r>
+              <a:rPr lang="en-GB" dirty="0"/>
+              <a:t> page</a:t>
+            </a:r>
+          </a:p>
+        </p:txBody>
+      </p:sp>
+      <p:pic>
+        <p:nvPicPr>
+          <p:cNvPr id="7" name="Picture 6" descr="A qr code on a white background&#10;&#10;AI-generated content may be incorrect.">
+            <a:extLst>
+              <a:ext uri="{FF2B5EF4-FFF2-40B4-BE49-F238E27FC236}">
+                <a16:creationId xmlns:a16="http://schemas.microsoft.com/office/drawing/2014/main" id="{AB721F09-844E-BA7F-9952-DEAB144E6D82}"/>
+              </a:ext>
+            </a:extLst>
+          </p:cNvPr>
+          <p:cNvPicPr>
+            <a:picLocks noChangeAspect="1"/>
+          </p:cNvPicPr>
+          <p:nvPr/>
+        </p:nvPicPr>
+        <p:blipFill>
+          <a:blip r:embed="rId3"/>
+          <a:stretch>
+            <a:fillRect/>
+          </a:stretch>
+        </p:blipFill>
+        <p:spPr>
+          <a:xfrm>
+            <a:off x="8593330" y="2569083"/>
+            <a:ext cx="2122430" cy="2743200"/>
+          </a:xfrm>
+          <a:prstGeom prst="rect">
+            <a:avLst/>
+          </a:prstGeom>
+        </p:spPr>
+      </p:pic>
+      <p:sp>
+        <p:nvSpPr>
+          <p:cNvPr id="8" name="TextBox 7">
+            <a:extLst>
+              <a:ext uri="{FF2B5EF4-FFF2-40B4-BE49-F238E27FC236}">
+                <a16:creationId xmlns:a16="http://schemas.microsoft.com/office/drawing/2014/main" id="{B4F02907-6B65-FB1B-C29B-7FE9B4838D67}"/>
+              </a:ext>
+            </a:extLst>
+          </p:cNvPr>
+          <p:cNvSpPr txBox="1"/>
+          <p:nvPr/>
+        </p:nvSpPr>
+        <p:spPr>
+          <a:xfrm>
+            <a:off x="4716820" y="5771746"/>
+            <a:ext cx="6094476" cy="830997"/>
+          </a:xfrm>
+          <a:prstGeom prst="rect">
+            <a:avLst/>
+          </a:prstGeom>
+          <a:noFill/>
+        </p:spPr>
+        <p:txBody>
+          <a:bodyPr wrap="square">
+            <a:spAutoFit/>
           </a:bodyPr>
           <a:lstStyle/>
           <a:p>
-            <a:pPr marL="0" indent="0">
-              <a:buNone/>
-            </a:pPr>
-            <a:r>
-              <a:rPr lang="en-US" sz="2400" dirty="0"/>
-              <a:t>Climate Change Data</a:t>
-            </a:r>
-          </a:p>
-          <a:p>
-            <a:pPr marL="0" indent="0">
-              <a:buNone/>
-            </a:pPr>
-            <a:endParaRPr lang="en-US" dirty="0"/>
-          </a:p>
-          <a:p>
-            <a:pPr marL="0" indent="0">
-              <a:buNone/>
-            </a:pPr>
-            <a:r>
-              <a:rPr lang="en-GB" sz="2200" dirty="0"/>
-              <a:t>Idea: </a:t>
-            </a:r>
-          </a:p>
-          <a:p>
-            <a:r>
-              <a:rPr lang="en-GB" sz="2200" b="1" dirty="0"/>
-              <a:t>Step 1:</a:t>
-            </a:r>
-            <a:r>
-              <a:rPr lang="en-GB" sz="2200" dirty="0"/>
-              <a:t> Present the complete climate change data walkthrough (HTML) with fill-in-the-blank code lines and interactive exercises. This gives the audience a clear picture of the final output we’re aiming for.</a:t>
-            </a:r>
-          </a:p>
-          <a:p>
-            <a:r>
-              <a:rPr lang="en-GB" sz="2200" b="1" dirty="0"/>
-              <a:t>Step 2:</a:t>
-            </a:r>
-            <a:r>
-              <a:rPr lang="en-GB" sz="2200" dirty="0"/>
-              <a:t> Provide the incomplete version of the climate change data R Markdown file (without the fill-in-the-blank code lines or interactive exercises) via a GitHub link or Posit Cloud. This version skips the text like aim and preparation to save time, allowing participants to focus on building the interactive components.</a:t>
-            </a:r>
-          </a:p>
-          <a:p>
-            <a:r>
-              <a:rPr lang="en-GB" sz="2200" b="1" dirty="0"/>
-              <a:t>Step 3:</a:t>
-            </a:r>
-            <a:r>
-              <a:rPr lang="en-GB" sz="2200" dirty="0"/>
-              <a:t> Guide the audience through adding the fill-in-the-blank code lines and creating the interactive exercises—hands-on practice.</a:t>
-            </a:r>
-          </a:p>
-          <a:p>
-            <a:pPr marL="0" indent="0">
-              <a:buNone/>
-            </a:pPr>
-            <a:endParaRPr lang="en-US" dirty="0"/>
+            <a:pPr algn="r"/>
+            <a:r>
+              <a:rPr lang="en-GB" sz="2400" dirty="0">
+                <a:hlinkClick r:id="rId4"/>
+              </a:rPr>
+              <a:t>https://datasquad.github.io/DEE2025_coding/</a:t>
+            </a:r>
+            <a:endParaRPr lang="en-GB" sz="2400" dirty="0"/>
+          </a:p>
+          <a:p>
+            <a:pPr algn="r"/>
+            <a:endParaRPr lang="en-GB" sz="2400" dirty="0"/>
           </a:p>
         </p:txBody>
       </p:sp>
@@ -24987,6 +25014,67 @@
               <a:rPr lang="en-US" dirty="0"/>
               <a:t>Invitation to follow-up or collaborate </a:t>
             </a:r>
+          </a:p>
+        </p:txBody>
+      </p:sp>
+      <p:sp>
+        <p:nvSpPr>
+          <p:cNvPr id="4" name="TextBox 3">
+            <a:extLst>
+              <a:ext uri="{FF2B5EF4-FFF2-40B4-BE49-F238E27FC236}">
+                <a16:creationId xmlns:a16="http://schemas.microsoft.com/office/drawing/2014/main" id="{31312F3E-BAEE-90FD-7DB5-BD468F11684C}"/>
+              </a:ext>
+            </a:extLst>
+          </p:cNvPr>
+          <p:cNvSpPr txBox="1"/>
+          <p:nvPr/>
+        </p:nvSpPr>
+        <p:spPr>
+          <a:xfrm>
+            <a:off x="838200" y="4114860"/>
+            <a:ext cx="7749301" cy="2492990"/>
+          </a:xfrm>
+          <a:prstGeom prst="rect">
+            <a:avLst/>
+          </a:prstGeom>
+          <a:noFill/>
+        </p:spPr>
+        <p:txBody>
+          <a:bodyPr wrap="none" rtlCol="0">
+            <a:spAutoFit/>
+          </a:bodyPr>
+          <a:lstStyle/>
+          <a:p>
+            <a:r>
+              <a:rPr lang="en-GB" sz="4400" dirty="0"/>
+              <a:t>Further Resources</a:t>
+            </a:r>
+          </a:p>
+          <a:p>
+            <a:endParaRPr lang="en-GB" sz="2800" dirty="0"/>
+          </a:p>
+          <a:p>
+            <a:pPr marL="285750" indent="-285750">
+              <a:buFont typeface="Arial" panose="020B0604020202020204" pitchFamily="34" charset="0"/>
+              <a:buChar char="•"/>
+            </a:pPr>
+            <a:r>
+              <a:rPr lang="en-GB" sz="2800" dirty="0"/>
+              <a:t>Econometric Computing Learning Resource (ECLR)</a:t>
+            </a:r>
+            <a:br>
+              <a:rPr lang="en-GB" sz="2800" dirty="0"/>
+            </a:br>
+            <a:r>
+              <a:rPr lang="en-GB" sz="2800" dirty="0">
+                <a:hlinkClick r:id="rId2"/>
+              </a:rPr>
+              <a:t>https://datasquad.github.io/ECLR/</a:t>
+            </a:r>
+            <a:endParaRPr lang="en-GB" sz="2800" dirty="0"/>
+          </a:p>
+          <a:p>
+            <a:endParaRPr lang="en-GB" sz="2800" dirty="0"/>
           </a:p>
         </p:txBody>
       </p:sp>

</xml_diff>